<commit_message>
Fix PowerPoint logo images for Google Slides import
</commit_message>
<xml_diff>
--- a/assets/slides/qsymb-editable.pptx
+++ b/assets/slides/qsymb-editable.pptx
@@ -3326,14 +3326,10 @@
           <p:nvPr/>
         </p:nvPicPr>
         <p:blipFill>
-          <a:blip xmlns:r="http://schemas.openxmlformats.org/officeDocument/2006/relationships" xmlns:a="http://schemas.openxmlformats.org/drawingml/2006/main" r:embed="Rcd3737e53bf04031">
-            <a:extLst>
-              <a:ext uri="{96DAC541-7B7A-43D3-8B79-37D633B846F1}">
-                <asvg:svgBlip xmlns:asvg="http://schemas.microsoft.com/office/drawing/2016/SVG/main" r:embed="R1d6178eb6be74707"/>
-              </a:ext>
-            </a:extLst>
-          </a:blip>
-          <a:stretch xmlns:a="http://schemas.openxmlformats.org/drawingml/2006/main"/>
+          <a:blip xmlns:r="http://schemas.openxmlformats.org/officeDocument/2006/relationships" xmlns:a="http://schemas.openxmlformats.org/drawingml/2006/main" r:embed="Rcd3737e53bf04031"/>
+          <a:stretch xmlns:a="http://schemas.openxmlformats.org/drawingml/2006/main">
+            <a:fillRect/>
+          </a:stretch>
         </p:blipFill>
         <p:spPr>
           <a:xfrm xmlns:a="http://schemas.openxmlformats.org/drawingml/2006/main">
@@ -3411,14 +3407,10 @@
           <p:nvPr/>
         </p:nvPicPr>
         <p:blipFill>
-          <a:blip xmlns:r="http://schemas.openxmlformats.org/officeDocument/2006/relationships" xmlns:a="http://schemas.openxmlformats.org/drawingml/2006/main" r:embed="Rbb904c6ddb5b4feb">
-            <a:extLst>
-              <a:ext uri="{96DAC541-7B7A-43D3-8B79-37D633B846F1}">
-                <asvg:svgBlip xmlns:asvg="http://schemas.microsoft.com/office/drawing/2016/SVG/main" r:embed="R88799c6bbeb94e52"/>
-              </a:ext>
-            </a:extLst>
-          </a:blip>
-          <a:stretch xmlns:a="http://schemas.openxmlformats.org/drawingml/2006/main"/>
+          <a:blip xmlns:r="http://schemas.openxmlformats.org/officeDocument/2006/relationships" xmlns:a="http://schemas.openxmlformats.org/drawingml/2006/main" r:embed="Rbb904c6ddb5b4feb"/>
+          <a:stretch xmlns:a="http://schemas.openxmlformats.org/drawingml/2006/main">
+            <a:fillRect/>
+          </a:stretch>
         </p:blipFill>
         <p:spPr>
           <a:xfrm xmlns:a="http://schemas.openxmlformats.org/drawingml/2006/main">

</xml_diff>

<commit_message>
Deploying to gh-pages from @ xiaoqiangheye/xiaoqiangheye.github.io@bef56b61e02b2c7bbd8ff3a5acfc31d235cff6bc 🚀
</commit_message>
<xml_diff>
--- a/assets/slides/qsymb-editable.pptx
+++ b/assets/slides/qsymb-editable.pptx
@@ -3326,14 +3326,10 @@
           <p:nvPr/>
         </p:nvPicPr>
         <p:blipFill>
-          <a:blip xmlns:r="http://schemas.openxmlformats.org/officeDocument/2006/relationships" xmlns:a="http://schemas.openxmlformats.org/drawingml/2006/main" r:embed="Rcd3737e53bf04031">
-            <a:extLst>
-              <a:ext uri="{96DAC541-7B7A-43D3-8B79-37D633B846F1}">
-                <asvg:svgBlip xmlns:asvg="http://schemas.microsoft.com/office/drawing/2016/SVG/main" r:embed="R1d6178eb6be74707"/>
-              </a:ext>
-            </a:extLst>
-          </a:blip>
-          <a:stretch xmlns:a="http://schemas.openxmlformats.org/drawingml/2006/main"/>
+          <a:blip xmlns:r="http://schemas.openxmlformats.org/officeDocument/2006/relationships" xmlns:a="http://schemas.openxmlformats.org/drawingml/2006/main" r:embed="Rcd3737e53bf04031"/>
+          <a:stretch xmlns:a="http://schemas.openxmlformats.org/drawingml/2006/main">
+            <a:fillRect/>
+          </a:stretch>
         </p:blipFill>
         <p:spPr>
           <a:xfrm xmlns:a="http://schemas.openxmlformats.org/drawingml/2006/main">
@@ -3411,14 +3407,10 @@
           <p:nvPr/>
         </p:nvPicPr>
         <p:blipFill>
-          <a:blip xmlns:r="http://schemas.openxmlformats.org/officeDocument/2006/relationships" xmlns:a="http://schemas.openxmlformats.org/drawingml/2006/main" r:embed="Rbb904c6ddb5b4feb">
-            <a:extLst>
-              <a:ext uri="{96DAC541-7B7A-43D3-8B79-37D633B846F1}">
-                <asvg:svgBlip xmlns:asvg="http://schemas.microsoft.com/office/drawing/2016/SVG/main" r:embed="R88799c6bbeb94e52"/>
-              </a:ext>
-            </a:extLst>
-          </a:blip>
-          <a:stretch xmlns:a="http://schemas.openxmlformats.org/drawingml/2006/main"/>
+          <a:blip xmlns:r="http://schemas.openxmlformats.org/officeDocument/2006/relationships" xmlns:a="http://schemas.openxmlformats.org/drawingml/2006/main" r:embed="Rbb904c6ddb5b4feb"/>
+          <a:stretch xmlns:a="http://schemas.openxmlformats.org/drawingml/2006/main">
+            <a:fillRect/>
+          </a:stretch>
         </p:blipFill>
         <p:spPr>
           <a:xfrm xmlns:a="http://schemas.openxmlformats.org/drawingml/2006/main">

</xml_diff>